<commit_message>
update index page, and PDF
</commit_message>
<xml_diff>
--- a/presentations/using_ai_code_asst.pptx
+++ b/presentations/using_ai_code_asst.pptx
@@ -569,7 +569,7 @@
       </p:grpSpPr>
       <p:sp>
         <p:nvSpPr>
-          <p:cNvPr id="177" name="Shape 177"/>
+          <p:cNvPr id="181" name="Shape 181"/>
           <p:cNvSpPr/>
           <p:nvPr>
             <p:ph type="sldImg"/>
@@ -590,7 +590,7 @@
       </p:sp>
       <p:sp>
         <p:nvSpPr>
-          <p:cNvPr id="178" name="Shape 178"/>
+          <p:cNvPr id="182" name="Shape 182"/>
           <p:cNvSpPr/>
           <p:nvPr>
             <p:ph type="body" sz="quarter" idx="1"/>
@@ -603,15 +603,26 @@
         </p:spPr>
         <p:txBody>
           <a:bodyPr/>
-          <a:lstStyle>
-            <a:lvl1pPr>
-              <a:defRPr sz="1800"/>
-            </a:lvl1pPr>
-          </a:lstStyle>
-          <a:p>
-            <a:pPr/>
-            <a:r>
-              <a:t>2026/01/13: </a:t>
+          <a:lstStyle/>
+          <a:p>
+            <a:pPr/>
+            <a:r>
+              <a:t>Note on IDE differences and also how different LLMS</a:t>
+            </a:r>
+          </a:p>
+          <a:p>
+            <a:pPr/>
+            <a:r>
+              <a:rPr u="sng">
+                <a:hlinkClick r:id="rId3" invalidUrl="" action="" tgtFrame="" tooltip="" history="1" highlightClick="0" endSnd="0"/>
+              </a:rPr>
+              <a:t>https://www.demandlab.com/resources/blog/5-takeaways-report-on-the-state-of-ai-in-business/</a:t>
+            </a:r>
+          </a:p>
+          <a:p>
+            <a:pPr/>
+            <a:r>
+              <a:t>https://www.aigl.blog/state-of-ai-in-business-2025/</a:t>
             </a:r>
           </a:p>
         </p:txBody>
@@ -643,7 +654,7 @@
       </p:grpSpPr>
       <p:sp>
         <p:nvSpPr>
-          <p:cNvPr id="273" name="Shape 273"/>
+          <p:cNvPr id="279" name="Shape 279"/>
           <p:cNvSpPr/>
           <p:nvPr>
             <p:ph type="sldImg"/>
@@ -664,7 +675,7 @@
       </p:sp>
       <p:sp>
         <p:nvSpPr>
-          <p:cNvPr id="274" name="Shape 274"/>
+          <p:cNvPr id="280" name="Shape 280"/>
           <p:cNvSpPr/>
           <p:nvPr>
             <p:ph type="body" sz="quarter" idx="1"/>
@@ -681,16 +692,7 @@
           <a:p>
             <a:pPr/>
             <a:r>
-              <a:t>NOTE: Racing to code / touching delivery-finish-line is not the goal — breaking down the specification; getting requirements right; understanding domain knowledge that’s the key, before you touch or start coding; this is not a one-man-job; a small team can ideally make the engineering practice a reality</a:t>
-            </a:r>
-          </a:p>
-          <a:p>
-            <a:pPr/>
-            <a:r>
-              <a:rPr u="sng">
-                <a:hlinkClick r:id="rId3" invalidUrl="" action="" tgtFrame="" tooltip="" history="1" highlightClick="0" endSnd="0"/>
-              </a:rPr>
-              <a:t>https://forum.cursor.com/t/i-created-an-amazing-mode-called-riper-5-mode-fixes-claude-3-7-drastically/65516</a:t>
+              <a:t>Get samples for different roles.. for both Agent and Skills</a:t>
             </a:r>
           </a:p>
         </p:txBody>
@@ -722,7 +724,7 @@
       </p:grpSpPr>
       <p:sp>
         <p:nvSpPr>
-          <p:cNvPr id="281" name="Shape 281"/>
+          <p:cNvPr id="284" name="Shape 284"/>
           <p:cNvSpPr/>
           <p:nvPr>
             <p:ph type="sldImg"/>
@@ -743,7 +745,7 @@
       </p:sp>
       <p:sp>
         <p:nvSpPr>
-          <p:cNvPr id="282" name="Shape 282"/>
+          <p:cNvPr id="285" name="Shape 285"/>
           <p:cNvSpPr/>
           <p:nvPr>
             <p:ph type="body" sz="quarter" idx="1"/>
@@ -760,7 +762,28 @@
           <a:p>
             <a:pPr/>
             <a:r>
-              <a:t>Get samples for different roles.. for both Agent and Skills</a:t>
+              <a:rPr u="sng">
+                <a:hlinkClick r:id="rId3" invalidUrl="" action="" tgtFrame="" tooltip="" history="1" highlightClick="0" endSnd="0"/>
+              </a:rPr>
+              <a:t>https://amitrajpurkar.github.io/</a:t>
+            </a:r>
+          </a:p>
+          <a:p>
+            <a:pPr/>
+            <a:r>
+              <a:t>I started experimenting with speckit since October 2025; I am still a novice at SPECs at Feb 2026, after about 6 experiment apps; getting maturity with SPECS, AGENTS, SKILLS will take time and effort. </a:t>
+            </a:r>
+          </a:p>
+          <a:p>
+            <a:pPr/>
+            <a:r>
+              <a:rPr u="sng">
+                <a:hlinkClick r:id="rId4" invalidUrl="" action="" tgtFrame="" tooltip="" history="1" highlightClick="0" endSnd="0"/>
+              </a:rPr>
+              <a:t>https://github.com/wesreisz-tw/icsaet-demo</a:t>
+            </a:r>
+            <a:r>
+              <a:t>  —&gt; check “specifications” folder to see what high-maturity-level specs look like</a:t>
             </a:r>
           </a:p>
         </p:txBody>
@@ -792,7 +815,7 @@
       </p:grpSpPr>
       <p:sp>
         <p:nvSpPr>
-          <p:cNvPr id="286" name="Shape 286"/>
+          <p:cNvPr id="293" name="Shape 293"/>
           <p:cNvSpPr/>
           <p:nvPr>
             <p:ph type="sldImg"/>
@@ -813,7 +836,7 @@
       </p:sp>
       <p:sp>
         <p:nvSpPr>
-          <p:cNvPr id="287" name="Shape 287"/>
+          <p:cNvPr id="294" name="Shape 294"/>
           <p:cNvSpPr/>
           <p:nvPr>
             <p:ph type="body" sz="quarter" idx="1"/>
@@ -827,31 +850,19 @@
         <p:txBody>
           <a:bodyPr/>
           <a:lstStyle/>
+          <a:p>
+            <a:pPr/>
+            <a:r>
+              <a:t>Do check the last link, an insightful session from Thoughtworks</a:t>
+            </a:r>
+          </a:p>
           <a:p>
             <a:pPr/>
             <a:r>
               <a:rPr u="sng">
                 <a:hlinkClick r:id="rId3" invalidUrl="" action="" tgtFrame="" tooltip="" history="1" highlightClick="0" endSnd="0"/>
               </a:rPr>
-              <a:t>https://amitrajpurkar.github.io/</a:t>
-            </a:r>
-          </a:p>
-          <a:p>
-            <a:pPr/>
-            <a:r>
-              <a:t>I started experimenting with speckit since October 2025; I am still a novice at SPECs at Feb 2026, after about 6 experiment apps; getting maturity with SPECS, AGENTS, SKILLS will take time and effort. </a:t>
-            </a:r>
-          </a:p>
-          <a:p>
-            <a:pPr/>
-            <a:r>
-              <a:rPr u="sng">
-                <a:hlinkClick r:id="rId4" invalidUrl="" action="" tgtFrame="" tooltip="" history="1" highlightClick="0" endSnd="0"/>
-              </a:rPr>
-              <a:t>https://github.com/wesreisz-tw/icsaet-demo</a:t>
-            </a:r>
-            <a:r>
-              <a:t>  —&gt; check “specifications” folder to see what high-maturity-level specs look like</a:t>
+              <a:t>https://www.infoq.com/presentations/chop-rag-llm-qcon/</a:t>
             </a:r>
           </a:p>
         </p:txBody>
@@ -883,7 +894,7 @@
       </p:grpSpPr>
       <p:sp>
         <p:nvSpPr>
-          <p:cNvPr id="295" name="Shape 295"/>
+          <p:cNvPr id="305" name="Shape 305"/>
           <p:cNvSpPr/>
           <p:nvPr>
             <p:ph type="sldImg"/>
@@ -904,86 +915,7 @@
       </p:sp>
       <p:sp>
         <p:nvSpPr>
-          <p:cNvPr id="296" name="Shape 296"/>
-          <p:cNvSpPr/>
-          <p:nvPr>
-            <p:ph type="body" sz="quarter" idx="1"/>
-          </p:nvPr>
-        </p:nvSpPr>
-        <p:spPr>
-          <a:prstGeom prst="rect">
-            <a:avLst/>
-          </a:prstGeom>
-        </p:spPr>
-        <p:txBody>
-          <a:bodyPr/>
-          <a:lstStyle/>
-          <a:p>
-            <a:pPr/>
-            <a:r>
-              <a:t>Do check the last link, an insightful session from Thoughtworks</a:t>
-            </a:r>
-          </a:p>
-          <a:p>
-            <a:pPr/>
-            <a:r>
-              <a:rPr u="sng">
-                <a:hlinkClick r:id="rId3" invalidUrl="" action="" tgtFrame="" tooltip="" history="1" highlightClick="0" endSnd="0"/>
-              </a:rPr>
-              <a:t>https://www.infoq.com/presentations/chop-rag-llm-qcon/</a:t>
-            </a:r>
-          </a:p>
-        </p:txBody>
-      </p:sp>
-    </p:spTree>
-  </p:cSld>
-  <p:clrMapOvr>
-    <a:masterClrMapping/>
-  </p:clrMapOvr>
-</p:notes>
-</file>
-
-<file path=ppt/notesSlides/notesSlide14.xml><?xml version="1.0" encoding="utf-8"?>
-<p:notes xmlns:a="http://schemas.openxmlformats.org/drawingml/2006/main" xmlns:r="http://schemas.openxmlformats.org/officeDocument/2006/relationships" xmlns:p="http://schemas.openxmlformats.org/presentationml/2006/main" xmlns:m="http://schemas.openxmlformats.org/officeDocument/2006/math" xmlns:a14="http://schemas.microsoft.com/office/drawing/2010/main" showMasterSp="1" showMasterPhAnim="1">
-  <p:cSld>
-    <p:spTree>
-      <p:nvGrpSpPr>
-        <p:cNvPr id="1" name=""/>
-        <p:cNvGrpSpPr/>
-        <p:nvPr/>
-      </p:nvGrpSpPr>
-      <p:grpSpPr>
-        <a:xfrm>
-          <a:off x="0" y="0"/>
-          <a:ext cx="0" cy="0"/>
-          <a:chOff x="0" y="0"/>
-          <a:chExt cx="0" cy="0"/>
-        </a:xfrm>
-      </p:grpSpPr>
-      <p:sp>
-        <p:nvSpPr>
-          <p:cNvPr id="307" name="Shape 307"/>
-          <p:cNvSpPr/>
-          <p:nvPr>
-            <p:ph type="sldImg"/>
-          </p:nvPr>
-        </p:nvSpPr>
-        <p:spPr>
-          <a:prstGeom prst="rect">
-            <a:avLst/>
-          </a:prstGeom>
-        </p:spPr>
-        <p:txBody>
-          <a:bodyPr/>
-          <a:lstStyle/>
-          <a:p>
-            <a:pPr/>
-          </a:p>
-        </p:txBody>
-      </p:sp>
-      <p:sp>
-        <p:nvSpPr>
-          <p:cNvPr id="308" name="Shape 308"/>
+          <p:cNvPr id="306" name="Shape 306"/>
           <p:cNvSpPr/>
           <p:nvPr>
             <p:ph type="body" sz="quarter" idx="1"/>
@@ -1032,7 +964,7 @@
       </p:grpSpPr>
       <p:sp>
         <p:nvSpPr>
-          <p:cNvPr id="183" name="Shape 183"/>
+          <p:cNvPr id="187" name="Shape 187"/>
           <p:cNvSpPr/>
           <p:nvPr>
             <p:ph type="sldImg"/>
@@ -1053,7 +985,7 @@
       </p:sp>
       <p:sp>
         <p:nvSpPr>
-          <p:cNvPr id="184" name="Shape 184"/>
+          <p:cNvPr id="188" name="Shape 188"/>
           <p:cNvSpPr/>
           <p:nvPr>
             <p:ph type="body" sz="quarter" idx="1"/>
@@ -1070,22 +1002,7 @@
           <a:p>
             <a:pPr/>
             <a:r>
-              <a:t>Note on IDE differences and also how different LLMS</a:t>
-            </a:r>
-          </a:p>
-          <a:p>
-            <a:pPr/>
-            <a:r>
-              <a:rPr u="sng">
-                <a:hlinkClick r:id="rId3" invalidUrl="" action="" tgtFrame="" tooltip="" history="1" highlightClick="0" endSnd="0"/>
-              </a:rPr>
-              <a:t>https://www.demandlab.com/resources/blog/5-takeaways-report-on-the-state-of-ai-in-business/</a:t>
-            </a:r>
-          </a:p>
-          <a:p>
-            <a:pPr/>
-            <a:r>
-              <a:t>https://www.aigl.blog/state-of-ai-in-business-2025/</a:t>
+              <a:t>I am personally using Windsurf; purchased Professional license</a:t>
             </a:r>
           </a:p>
         </p:txBody>
@@ -1117,7 +1034,7 @@
       </p:grpSpPr>
       <p:sp>
         <p:nvSpPr>
-          <p:cNvPr id="189" name="Shape 189"/>
+          <p:cNvPr id="201" name="Shape 201"/>
           <p:cNvSpPr/>
           <p:nvPr>
             <p:ph type="sldImg"/>
@@ -1138,7 +1055,7 @@
       </p:sp>
       <p:sp>
         <p:nvSpPr>
-          <p:cNvPr id="190" name="Shape 190"/>
+          <p:cNvPr id="202" name="Shape 202"/>
           <p:cNvSpPr/>
           <p:nvPr>
             <p:ph type="body" sz="quarter" idx="1"/>
@@ -1155,7 +1072,22 @@
           <a:p>
             <a:pPr/>
             <a:r>
-              <a:t>I am personally using Windsurf; purchased Professional license</a:t>
+              <a:rPr u="sng">
+                <a:hlinkClick r:id="rId3" invalidUrl="" action="" tgtFrame="" tooltip="" history="1" highlightClick="0" endSnd="0"/>
+              </a:rPr>
+              <a:t>https://github.com/github/spec-kit</a:t>
+            </a:r>
+          </a:p>
+          <a:p>
+            <a:pPr/>
+            <a:r>
+              <a:t>Though this information is pulled from ChatGPT and Poe, these snippets are valuable.</a:t>
+            </a:r>
+          </a:p>
+          <a:p>
+            <a:pPr/>
+            <a:r>
+              <a:t>I am experimenting with SpecKit on a couple of apps.. so far so good.</a:t>
             </a:r>
           </a:p>
         </p:txBody>
@@ -1187,7 +1119,7 @@
       </p:grpSpPr>
       <p:sp>
         <p:nvSpPr>
-          <p:cNvPr id="203" name="Shape 203"/>
+          <p:cNvPr id="211" name="Shape 211"/>
           <p:cNvSpPr/>
           <p:nvPr>
             <p:ph type="sldImg"/>
@@ -1208,7 +1140,7 @@
       </p:sp>
       <p:sp>
         <p:nvSpPr>
-          <p:cNvPr id="204" name="Shape 204"/>
+          <p:cNvPr id="212" name="Shape 212"/>
           <p:cNvSpPr/>
           <p:nvPr>
             <p:ph type="body" sz="quarter" idx="1"/>
@@ -1222,25 +1154,40 @@
         <p:txBody>
           <a:bodyPr/>
           <a:lstStyle/>
+          <a:p>
+            <a:pPr/>
+            <a:r>
+              <a:t>Know more: Speckit only shows us one way to introduce specifications into our development workflow. As you mature into this process, you can evolve your own specification template or even hand-craft your own specifications for the application or project</a:t>
+            </a:r>
+          </a:p>
           <a:p>
             <a:pPr/>
             <a:r>
               <a:rPr u="sng">
                 <a:hlinkClick r:id="rId3" invalidUrl="" action="" tgtFrame="" tooltip="" history="1" highlightClick="0" endSnd="0"/>
               </a:rPr>
-              <a:t>https://github.com/github/spec-kit</a:t>
-            </a:r>
-          </a:p>
-          <a:p>
-            <a:pPr/>
-            <a:r>
-              <a:t>Though this information is pulled from ChatGPT and Poe, these snippets are valuable.</a:t>
-            </a:r>
-          </a:p>
-          <a:p>
-            <a:pPr/>
-            <a:r>
-              <a:t>I am experimenting with SpecKit on a couple of apps.. so far so good.</a:t>
+              <a:t>https://github.com/johnpeterman72/CursorRIPER</a:t>
+            </a:r>
+            <a:r>
+              <a:t>. —&gt; RIPER = Research-Innovate-Plan-Execute-Review loop</a:t>
+            </a:r>
+          </a:p>
+          <a:p>
+            <a:pPr/>
+            <a:r>
+              <a:rPr u="sng">
+                <a:hlinkClick r:id="rId4" invalidUrl="" action="" tgtFrame="" tooltip="" history="1" highlightClick="0" endSnd="0"/>
+              </a:rPr>
+              <a:t>https://www.kzsoftworks.com/blog/windsurf-workflows-from-prompt-chaos-to-productive-focus</a:t>
+            </a:r>
+          </a:p>
+          <a:p>
+            <a:pPr/>
+            <a:r>
+              <a:rPr u="sng">
+                <a:hlinkClick r:id="rId5" invalidUrl="" action="" tgtFrame="" tooltip="" history="1" highlightClick="0" endSnd="0"/>
+              </a:rPr>
+              <a:t>https://github.com/kzsoftworks/windsurf-workflows</a:t>
             </a:r>
           </a:p>
         </p:txBody>
@@ -1272,7 +1219,7 @@
       </p:grpSpPr>
       <p:sp>
         <p:nvSpPr>
-          <p:cNvPr id="213" name="Shape 213"/>
+          <p:cNvPr id="235" name="Shape 235"/>
           <p:cNvSpPr/>
           <p:nvPr>
             <p:ph type="sldImg"/>
@@ -1293,7 +1240,7 @@
       </p:sp>
       <p:sp>
         <p:nvSpPr>
-          <p:cNvPr id="214" name="Shape 214"/>
+          <p:cNvPr id="236" name="Shape 236"/>
           <p:cNvSpPr/>
           <p:nvPr>
             <p:ph type="body" sz="quarter" idx="1"/>
@@ -1310,37 +1257,7 @@
           <a:p>
             <a:pPr/>
             <a:r>
-              <a:t>Know more: Speckit only shows us one way to introduce specifications into our development workflow. As you mature into this process, you can evolve your own specification template or even hand-craft your own specifications for the application or project</a:t>
-            </a:r>
-          </a:p>
-          <a:p>
-            <a:pPr/>
-            <a:r>
-              <a:rPr u="sng">
-                <a:hlinkClick r:id="rId3" invalidUrl="" action="" tgtFrame="" tooltip="" history="1" highlightClick="0" endSnd="0"/>
-              </a:rPr>
-              <a:t>https://github.com/johnpeterman72/CursorRIPER</a:t>
-            </a:r>
-            <a:r>
-              <a:t>. —&gt; RIPER = Research-Innovate-Plan-Execute-Review loop</a:t>
-            </a:r>
-          </a:p>
-          <a:p>
-            <a:pPr/>
-            <a:r>
-              <a:rPr u="sng">
-                <a:hlinkClick r:id="rId4" invalidUrl="" action="" tgtFrame="" tooltip="" history="1" highlightClick="0" endSnd="0"/>
-              </a:rPr>
-              <a:t>https://www.kzsoftworks.com/blog/windsurf-workflows-from-prompt-chaos-to-productive-focus</a:t>
-            </a:r>
-          </a:p>
-          <a:p>
-            <a:pPr/>
-            <a:r>
-              <a:rPr u="sng">
-                <a:hlinkClick r:id="rId5" invalidUrl="" action="" tgtFrame="" tooltip="" history="1" highlightClick="0" endSnd="0"/>
-              </a:rPr>
-              <a:t>https://github.com/kzsoftworks/windsurf-workflows</a:t>
+              <a:t>More commands are being released as time progresses; Above was true as of Nov 2025; as of 2026-02-08 I am seeing newer commands: “checklist”, “taskstoissues”; </a:t>
             </a:r>
           </a:p>
         </p:txBody>
@@ -1372,7 +1289,7 @@
       </p:grpSpPr>
       <p:sp>
         <p:nvSpPr>
-          <p:cNvPr id="237" name="Shape 237"/>
+          <p:cNvPr id="244" name="Shape 244"/>
           <p:cNvSpPr/>
           <p:nvPr>
             <p:ph type="sldImg"/>
@@ -1393,7 +1310,7 @@
       </p:sp>
       <p:sp>
         <p:nvSpPr>
-          <p:cNvPr id="238" name="Shape 238"/>
+          <p:cNvPr id="245" name="Shape 245"/>
           <p:cNvSpPr/>
           <p:nvPr>
             <p:ph type="body" sz="quarter" idx="1"/>
@@ -1410,7 +1327,37 @@
           <a:p>
             <a:pPr/>
             <a:r>
-              <a:t>More commands are being released as time progresses; Above was true as of Nov 2025; as of 2026-02-08 I am seeing newer commands: “checklist”, “taskstoissues”; </a:t>
+              <a:rPr u="sng">
+                <a:hlinkClick r:id="rId3" invalidUrl="" action="" tgtFrame="" tooltip="" history="1" highlightClick="0" endSnd="0"/>
+              </a:rPr>
+              <a:t>https://github.com/anthropics/skills</a:t>
+            </a:r>
+          </a:p>
+          <a:p>
+            <a:pPr/>
+            <a:r>
+              <a:t>Experimentation on Skills is yet to start. Collect samples of Skills, experiment, tweak.</a:t>
+            </a:r>
+          </a:p>
+          <a:p>
+            <a:pPr/>
+            <a:r>
+              <a:t>Try using Skills with Speckit.. need to understand how it works</a:t>
+            </a:r>
+          </a:p>
+          <a:p>
+            <a:pPr/>
+            <a:r>
+              <a:t>And then revise here, what are the benefits I see plus any other feedback </a:t>
+            </a:r>
+          </a:p>
+          <a:p>
+            <a:pPr/>
+            <a:r>
+              <a:rPr u="sng">
+                <a:hlinkClick r:id="rId4" invalidUrl="" action="" tgtFrame="" tooltip="" history="1" highlightClick="0" endSnd="0"/>
+              </a:rPr>
+              <a:t>https://docs.windsurf.com/windsurf/cascade/skills</a:t>
             </a:r>
           </a:p>
         </p:txBody>
@@ -1442,7 +1389,7 @@
       </p:grpSpPr>
       <p:sp>
         <p:nvSpPr>
-          <p:cNvPr id="246" name="Shape 246"/>
+          <p:cNvPr id="259" name="Shape 259"/>
           <p:cNvSpPr/>
           <p:nvPr>
             <p:ph type="sldImg"/>
@@ -1463,7 +1410,7 @@
       </p:sp>
       <p:sp>
         <p:nvSpPr>
-          <p:cNvPr id="247" name="Shape 247"/>
+          <p:cNvPr id="260" name="Shape 260"/>
           <p:cNvSpPr/>
           <p:nvPr>
             <p:ph type="body" sz="quarter" idx="1"/>
@@ -1477,31 +1424,31 @@
         <p:txBody>
           <a:bodyPr/>
           <a:lstStyle/>
+          <a:p>
+            <a:pPr/>
+            <a:r>
+              <a:t>https://agents.md/</a:t>
+            </a:r>
+          </a:p>
+          <a:p>
+            <a:pPr/>
+            <a:r>
+              <a:t>Need to Experiment Agent.md … need to explicitly invoke this alongside Speckit</a:t>
+            </a:r>
+          </a:p>
+          <a:p>
+            <a:pPr/>
+            <a:r>
+              <a:t>Capture a bunch of samples for Agent files… for different roles in SDLC and different types of Developers/ architects; Java, Python, React and Frontend expert, etc</a:t>
+            </a:r>
+          </a:p>
           <a:p>
             <a:pPr/>
             <a:r>
               <a:rPr u="sng">
                 <a:hlinkClick r:id="rId3" invalidUrl="" action="" tgtFrame="" tooltip="" history="1" highlightClick="0" endSnd="0"/>
               </a:rPr>
-              <a:t>https://github.com/anthropics/skills</a:t>
-            </a:r>
-          </a:p>
-          <a:p>
-            <a:pPr/>
-            <a:r>
-              <a:t>Experimentation on Skills is yet to start. Collect samples of Skills, experiment, tweak.</a:t>
-            </a:r>
-          </a:p>
-          <a:p>
-            <a:pPr/>
-            <a:r>
-              <a:t>Try using Skills with Speckit.. need to understand how it works</a:t>
-            </a:r>
-          </a:p>
-          <a:p>
-            <a:pPr/>
-            <a:r>
-              <a:t>And then revise here, what are the benefits I see plus any other feedback </a:t>
+              <a:t>https://www.scriptbyai.com/best-agent-skills/#google_vignette</a:t>
             </a:r>
           </a:p>
           <a:p>
@@ -1510,7 +1457,43 @@
               <a:rPr u="sng">
                 <a:hlinkClick r:id="rId4" invalidUrl="" action="" tgtFrame="" tooltip="" history="1" highlightClick="0" endSnd="0"/>
               </a:rPr>
-              <a:t>https://docs.windsurf.com/windsurf/cascade/skills</a:t>
+              <a:t>https://github.com/obra/superpowers/tree/main/skills</a:t>
+            </a:r>
+          </a:p>
+          <a:p>
+            <a:pPr/>
+            <a:r>
+              <a:rPr u="sng">
+                <a:hlinkClick r:id="rId5" invalidUrl="" action="" tgtFrame="" tooltip="" history="1" highlightClick="0" endSnd="0"/>
+              </a:rPr>
+              <a:t>https://github.com/vercel-labs/agent-skills</a:t>
+            </a:r>
+          </a:p>
+          <a:p>
+            <a:pPr/>
+            <a:r>
+              <a:rPr u="sng">
+                <a:hlinkClick r:id="rId6" invalidUrl="" action="" tgtFrame="" tooltip="" history="1" highlightClick="0" endSnd="0"/>
+              </a:rPr>
+              <a:t>https://github.com/OthmanAdi/planning-with-files</a:t>
+            </a:r>
+          </a:p>
+          <a:p>
+            <a:pPr/>
+            <a:r>
+              <a:rPr u="sng">
+                <a:hlinkClick r:id="rId7" invalidUrl="" action="" tgtFrame="" tooltip="" history="1" highlightClick="0" endSnd="0"/>
+              </a:rPr>
+              <a:t>https://github.com/muratcankoylan/Agent-Skills-for-Context-Engineering</a:t>
+            </a:r>
+          </a:p>
+          <a:p>
+            <a:pPr/>
+            <a:r>
+              <a:rPr u="sng">
+                <a:hlinkClick r:id="rId8" invalidUrl="" action="" tgtFrame="" tooltip="" history="1" highlightClick="0" endSnd="0"/>
+              </a:rPr>
+              <a:t>https://github.com/K-Dense-AI/claude-scientific-skills</a:t>
             </a:r>
           </a:p>
         </p:txBody>
@@ -1542,7 +1525,7 @@
       </p:grpSpPr>
       <p:sp>
         <p:nvSpPr>
-          <p:cNvPr id="261" name="Shape 261"/>
+          <p:cNvPr id="265" name="Shape 265"/>
           <p:cNvSpPr/>
           <p:nvPr>
             <p:ph type="sldImg"/>
@@ -1563,7 +1546,7 @@
       </p:sp>
       <p:sp>
         <p:nvSpPr>
-          <p:cNvPr id="262" name="Shape 262"/>
+          <p:cNvPr id="266" name="Shape 266"/>
           <p:cNvSpPr/>
           <p:nvPr>
             <p:ph type="body" sz="quarter" idx="1"/>
@@ -1580,19 +1563,7 @@
           <a:p>
             <a:pPr/>
             <a:r>
-              <a:t>https://agents.md/</a:t>
-            </a:r>
-          </a:p>
-          <a:p>
-            <a:pPr/>
-            <a:r>
-              <a:t>Need to Experiment Agent.md … need to explicitly invoke this alongside Speckit</a:t>
-            </a:r>
-          </a:p>
-          <a:p>
-            <a:pPr/>
-            <a:r>
-              <a:t>Capture a bunch of samples for Agent files… for different roles in SDLC and different types of Developers/ architects; Java, Python, React and Frontend expert, etc</a:t>
+              <a:t>NOTE: a developer typically builds his toolkit, evolve/ maintain AGENTS.md for java-developer, one for python-developer, react-developer, etc; build up Skills library: code-review, CI-CD, deployment; request-validations; etc; </a:t>
             </a:r>
           </a:p>
           <a:p>
@@ -1601,52 +1572,7 @@
               <a:rPr u="sng">
                 <a:hlinkClick r:id="rId3" invalidUrl="" action="" tgtFrame="" tooltip="" history="1" highlightClick="0" endSnd="0"/>
               </a:rPr>
-              <a:t>https://www.scriptbyai.com/best-agent-skills/#google_vignette</a:t>
-            </a:r>
-          </a:p>
-          <a:p>
-            <a:pPr/>
-            <a:r>
-              <a:rPr u="sng">
-                <a:hlinkClick r:id="rId4" invalidUrl="" action="" tgtFrame="" tooltip="" history="1" highlightClick="0" endSnd="0"/>
-              </a:rPr>
-              <a:t>https://github.com/obra/superpowers/tree/main/skills</a:t>
-            </a:r>
-          </a:p>
-          <a:p>
-            <a:pPr/>
-            <a:r>
-              <a:rPr u="sng">
-                <a:hlinkClick r:id="rId5" invalidUrl="" action="" tgtFrame="" tooltip="" history="1" highlightClick="0" endSnd="0"/>
-              </a:rPr>
-              <a:t>https://github.com/vercel-labs/agent-skills</a:t>
-            </a:r>
-          </a:p>
-          <a:p>
-            <a:pPr/>
-            <a:r>
-              <a:rPr u="sng">
-                <a:hlinkClick r:id="rId6" invalidUrl="" action="" tgtFrame="" tooltip="" history="1" highlightClick="0" endSnd="0"/>
-              </a:rPr>
-              <a:t>https://github.com/OthmanAdi/planning-with-files</a:t>
-            </a:r>
-          </a:p>
-          <a:p>
-            <a:pPr/>
-            <a:r>
-              <a:rPr u="sng">
-                <a:hlinkClick r:id="rId7" invalidUrl="" action="" tgtFrame="" tooltip="" history="1" highlightClick="0" endSnd="0"/>
-              </a:rPr>
-              <a:t>https://github.com/muratcankoylan/Agent-Skills-for-Context-Engineering</a:t>
-            </a:r>
-          </a:p>
-          <a:p>
-            <a:pPr/>
-            <a:r>
-              <a:rPr u="sng">
-                <a:hlinkClick r:id="rId8" invalidUrl="" action="" tgtFrame="" tooltip="" history="1" highlightClick="0" endSnd="0"/>
-              </a:rPr>
-              <a:t>https://github.com/K-Dense-AI/claude-scientific-skills</a:t>
+              <a:t>https://github.com/ComposioHQ/awesome-claude-skills</a:t>
             </a:r>
           </a:p>
         </p:txBody>
@@ -1678,7 +1604,7 @@
       </p:grpSpPr>
       <p:sp>
         <p:nvSpPr>
-          <p:cNvPr id="267" name="Shape 267"/>
+          <p:cNvPr id="271" name="Shape 271"/>
           <p:cNvSpPr/>
           <p:nvPr>
             <p:ph type="sldImg"/>
@@ -1699,7 +1625,7 @@
       </p:sp>
       <p:sp>
         <p:nvSpPr>
-          <p:cNvPr id="268" name="Shape 268"/>
+          <p:cNvPr id="272" name="Shape 272"/>
           <p:cNvSpPr/>
           <p:nvPr>
             <p:ph type="body" sz="quarter" idx="1"/>
@@ -1716,7 +1642,7 @@
           <a:p>
             <a:pPr/>
             <a:r>
-              <a:t>NOTE: a developer typically builds his toolkit, evolve/ maintain AGENTS.md for java-developer, one for python-developer, react-developer, etc; build up Skills library: code-review, CI-CD, deployment; request-validations; etc; </a:t>
+              <a:t>NOTE: Racing to code / touching delivery-finish-line is not the goal — breaking down the specification; getting requirements right; understanding domain knowledge that’s the key, before you touch or start coding; this is not a one-man-job; a small team can ideally make the engineering practice a reality</a:t>
             </a:r>
           </a:p>
           <a:p>
@@ -1725,7 +1651,7 @@
               <a:rPr u="sng">
                 <a:hlinkClick r:id="rId3" invalidUrl="" action="" tgtFrame="" tooltip="" history="1" highlightClick="0" endSnd="0"/>
               </a:rPr>
-              <a:t>https://github.com/ComposioHQ/awesome-claude-skills</a:t>
+              <a:t>https://forum.cursor.com/t/i-created-an-amazing-mode-called-riper-5-mode-fixes-claude-3-7-drastically/65516</a:t>
             </a:r>
           </a:p>
         </p:txBody>
@@ -5615,7 +5541,7 @@
       </p:grpSpPr>
       <p:sp>
         <p:nvSpPr>
-          <p:cNvPr id="240" name="When working with AI Coding Assistants"/>
+          <p:cNvPr id="238" name="When working with AI Coding Assistants"/>
           <p:cNvSpPr txBox="1"/>
           <p:nvPr>
             <p:ph type="body" idx="21"/>
@@ -5648,7 +5574,7 @@
       </p:sp>
       <p:sp>
         <p:nvSpPr>
-          <p:cNvPr id="241" name="Things to know: Skills"/>
+          <p:cNvPr id="239" name="Things to know: Skills"/>
           <p:cNvSpPr txBox="1"/>
           <p:nvPr>
             <p:ph type="title"/>
@@ -5680,7 +5606,7 @@
       </p:sp>
       <p:sp>
         <p:nvSpPr>
-          <p:cNvPr id="242" name="spec-kit = “what good looks like”…"/>
+          <p:cNvPr id="240" name="spec-kit = “what good looks like”…"/>
           <p:cNvSpPr txBox="1"/>
           <p:nvPr>
             <p:ph type="body" sz="quarter" idx="1"/>
@@ -5790,7 +5716,7 @@
       </p:sp>
       <p:pic>
         <p:nvPicPr>
-          <p:cNvPr id="243" name="pasted-movie.png" descr="pasted-movie.png"/>
+          <p:cNvPr id="241" name="pasted-movie.png" descr="pasted-movie.png"/>
           <p:cNvPicPr>
             <a:picLocks noChangeAspect="1"/>
           </p:cNvPicPr>
@@ -5819,7 +5745,7 @@
       </p:pic>
       <p:pic>
         <p:nvPicPr>
-          <p:cNvPr id="244" name="pasted-movie.png" descr="pasted-movie.png"/>
+          <p:cNvPr id="242" name="pasted-movie.png" descr="pasted-movie.png"/>
           <p:cNvPicPr>
             <a:picLocks noChangeAspect="1"/>
           </p:cNvPicPr>
@@ -5848,7 +5774,7 @@
       </p:pic>
       <p:pic>
         <p:nvPicPr>
-          <p:cNvPr id="245" name="pasted-movie.png" descr="pasted-movie.png"/>
+          <p:cNvPr id="243" name="pasted-movie.png" descr="pasted-movie.png"/>
           <p:cNvPicPr>
             <a:picLocks noChangeAspect="1"/>
           </p:cNvPicPr>
@@ -5903,7 +5829,7 @@
       </p:grpSpPr>
       <p:sp>
         <p:nvSpPr>
-          <p:cNvPr id="249" name="These two can co-exist and complement each other"/>
+          <p:cNvPr id="247" name="These two can co-exist and complement each other"/>
           <p:cNvSpPr txBox="1"/>
           <p:nvPr>
             <p:ph type="body" idx="21"/>
@@ -5932,7 +5858,7 @@
       </p:sp>
       <p:sp>
         <p:nvSpPr>
-          <p:cNvPr id="250" name="SpecKit with Skills"/>
+          <p:cNvPr id="248" name="SpecKit with Skills"/>
           <p:cNvSpPr txBox="1"/>
           <p:nvPr>
             <p:ph type="title"/>
@@ -5960,7 +5886,7 @@
       </p:sp>
       <p:sp>
         <p:nvSpPr>
-          <p:cNvPr id="251" name="spec-kit governs what should be built and why…"/>
+          <p:cNvPr id="249" name="spec-kit governs what should be built and why…"/>
           <p:cNvSpPr txBox="1"/>
           <p:nvPr>
             <p:ph type="body" sz="half" idx="1"/>
@@ -6117,7 +6043,7 @@
       </p:sp>
       <p:pic>
         <p:nvPicPr>
-          <p:cNvPr id="252" name="pasted-movie.png" descr="pasted-movie.png"/>
+          <p:cNvPr id="250" name="pasted-movie.png" descr="pasted-movie.png"/>
           <p:cNvPicPr>
             <a:picLocks noChangeAspect="1"/>
           </p:cNvPicPr>
@@ -6146,7 +6072,7 @@
       </p:pic>
       <p:pic>
         <p:nvPicPr>
-          <p:cNvPr id="253" name="pasted-movie.png" descr="pasted-movie.png"/>
+          <p:cNvPr id="251" name="pasted-movie.png" descr="pasted-movie.png"/>
           <p:cNvPicPr>
             <a:picLocks noChangeAspect="1"/>
           </p:cNvPicPr>
@@ -6201,7 +6127,7 @@
       </p:grpSpPr>
       <p:sp>
         <p:nvSpPr>
-          <p:cNvPr id="255" name="One more markdown you will hear"/>
+          <p:cNvPr id="253" name="One more markdown you will hear"/>
           <p:cNvSpPr txBox="1"/>
           <p:nvPr>
             <p:ph type="body" idx="21"/>
@@ -6234,7 +6160,7 @@
       </p:sp>
       <p:sp>
         <p:nvSpPr>
-          <p:cNvPr id="256" name="Agent.md"/>
+          <p:cNvPr id="254" name="Agent.md"/>
           <p:cNvSpPr txBox="1"/>
           <p:nvPr>
             <p:ph type="title"/>
@@ -6266,7 +6192,7 @@
       </p:sp>
       <p:sp>
         <p:nvSpPr>
-          <p:cNvPr id="257" name="AGENT.md defines how the AI behaves…"/>
+          <p:cNvPr id="255" name="AGENT.md defines how the AI behaves…"/>
           <p:cNvSpPr txBox="1"/>
           <p:nvPr>
             <p:ph type="body" sz="half" idx="1"/>
@@ -6426,7 +6352,7 @@
       </p:sp>
       <p:pic>
         <p:nvPicPr>
-          <p:cNvPr id="258" name="pasted-movie.png" descr="pasted-movie.png"/>
+          <p:cNvPr id="256" name="pasted-movie.png" descr="pasted-movie.png"/>
           <p:cNvPicPr>
             <a:picLocks noChangeAspect="1"/>
           </p:cNvPicPr>
@@ -6455,7 +6381,7 @@
       </p:pic>
       <p:pic>
         <p:nvPicPr>
-          <p:cNvPr id="259" name="pasted-movie.png" descr="pasted-movie.png"/>
+          <p:cNvPr id="257" name="pasted-movie.png" descr="pasted-movie.png"/>
           <p:cNvPicPr>
             <a:picLocks noChangeAspect="1"/>
           </p:cNvPicPr>
@@ -6484,7 +6410,7 @@
       </p:pic>
       <p:pic>
         <p:nvPicPr>
-          <p:cNvPr id="260" name="pasted-movie.png" descr="pasted-movie.png"/>
+          <p:cNvPr id="258" name="pasted-movie.png" descr="pasted-movie.png"/>
           <p:cNvPicPr>
             <a:picLocks noChangeAspect="1"/>
           </p:cNvPicPr>
@@ -6539,7 +6465,7 @@
       </p:grpSpPr>
       <p:sp>
         <p:nvSpPr>
-          <p:cNvPr id="264" name="Which one fits where ??"/>
+          <p:cNvPr id="262" name="Which one fits where ??"/>
           <p:cNvSpPr txBox="1"/>
           <p:nvPr>
             <p:ph type="body" idx="21"/>
@@ -6568,7 +6494,7 @@
       </p:sp>
       <p:sp>
         <p:nvSpPr>
-          <p:cNvPr id="265" name="AGENTS.md vs SPECS vs SKILLS"/>
+          <p:cNvPr id="263" name="AGENTS.md vs SPECS vs SKILLS"/>
           <p:cNvSpPr txBox="1"/>
           <p:nvPr>
             <p:ph type="title"/>
@@ -6596,7 +6522,7 @@
       </p:sp>
       <p:graphicFrame>
         <p:nvGraphicFramePr>
-          <p:cNvPr id="266" name="Table 1"/>
+          <p:cNvPr id="264" name="Table 1"/>
           <p:cNvGraphicFramePr/>
           <p:nvPr/>
         </p:nvGraphicFramePr>
@@ -7180,7 +7106,7 @@
       </p:grpSpPr>
       <p:sp>
         <p:nvSpPr>
-          <p:cNvPr id="270" name="“If AI is doing more of the typing, what must I still be good at so the system doesn’t collapse?”"/>
+          <p:cNvPr id="268" name="“If AI is doing more of the typing, what must I still be good at so the system doesn’t collapse?”"/>
           <p:cNvSpPr txBox="1"/>
           <p:nvPr>
             <p:ph type="body" idx="21"/>
@@ -7242,7 +7168,7 @@
       </p:sp>
       <p:sp>
         <p:nvSpPr>
-          <p:cNvPr id="271" name="So… the Developers part in this ??"/>
+          <p:cNvPr id="269" name="So… the Developers part in this ??"/>
           <p:cNvSpPr txBox="1"/>
           <p:nvPr>
             <p:ph type="title"/>
@@ -7270,7 +7196,7 @@
       </p:sp>
       <p:sp>
         <p:nvSpPr>
-          <p:cNvPr id="272" name="Non-negotiable: AI amplifies skills; it does not replace Developer’s skills…"/>
+          <p:cNvPr id="270" name="Non-negotiable: AI amplifies skills; it does not replace Developer’s skills…"/>
           <p:cNvSpPr txBox="1"/>
           <p:nvPr>
             <p:ph type="body" idx="1"/>
@@ -7421,7 +7347,7 @@
       </p:grpSpPr>
       <p:sp>
         <p:nvSpPr>
-          <p:cNvPr id="276" name="Analysts, Testers, Project Managers, Architects…"/>
+          <p:cNvPr id="274" name="Analysts, Testers, Project Managers, Architects…"/>
           <p:cNvSpPr txBox="1"/>
           <p:nvPr>
             <p:ph type="body" idx="21"/>
@@ -7450,7 +7376,7 @@
       </p:sp>
       <p:sp>
         <p:nvSpPr>
-          <p:cNvPr id="277" name="For other roles in SDLC"/>
+          <p:cNvPr id="275" name="For other roles in SDLC"/>
           <p:cNvSpPr txBox="1"/>
           <p:nvPr>
             <p:ph type="title"/>
@@ -7478,7 +7404,7 @@
       </p:sp>
       <p:sp>
         <p:nvSpPr>
-          <p:cNvPr id="278" name="Agent.md, Specs and Skills each generate good amount of documentation; though it appears to be dev-centric…"/>
+          <p:cNvPr id="276" name="Agent.md, Specs and Skills each generate good amount of documentation; though it appears to be dev-centric…"/>
           <p:cNvSpPr txBox="1"/>
           <p:nvPr>
             <p:ph type="body" sz="half" idx="1"/>
@@ -7555,7 +7481,7 @@
       </p:sp>
       <p:pic>
         <p:nvPicPr>
-          <p:cNvPr id="279" name="pasted-movie.png" descr="pasted-movie.png"/>
+          <p:cNvPr id="277" name="pasted-movie.png" descr="pasted-movie.png"/>
           <p:cNvPicPr>
             <a:picLocks noChangeAspect="1"/>
           </p:cNvPicPr>
@@ -7584,7 +7510,7 @@
       </p:pic>
       <p:pic>
         <p:nvPicPr>
-          <p:cNvPr id="280" name="pasted-movie.png" descr="pasted-movie.png"/>
+          <p:cNvPr id="278" name="pasted-movie.png" descr="pasted-movie.png"/>
           <p:cNvPicPr>
             <a:picLocks noChangeAspect="1"/>
           </p:cNvPicPr>
@@ -7639,7 +7565,7 @@
       </p:grpSpPr>
       <p:sp>
         <p:nvSpPr>
-          <p:cNvPr id="284" name="Planning to work with AI"/>
+          <p:cNvPr id="282" name="Planning to work with AI"/>
           <p:cNvSpPr txBox="1"/>
           <p:nvPr>
             <p:ph type="title"/>
@@ -7667,7 +7593,7 @@
       </p:sp>
       <p:sp>
         <p:nvSpPr>
-          <p:cNvPr id="285" name="How I planned/ broke-down migration effort into phases and steps for making changes…"/>
+          <p:cNvPr id="283" name="How I planned/ broke-down migration effort into phases and steps for making changes…"/>
           <p:cNvSpPr txBox="1"/>
           <p:nvPr>
             <p:ph type="body" idx="1"/>
@@ -7745,7 +7671,7 @@
       </p:grpSpPr>
       <p:sp>
         <p:nvSpPr>
-          <p:cNvPr id="289" name="Ending thoughts"/>
+          <p:cNvPr id="287" name="Ending thoughts"/>
           <p:cNvSpPr txBox="1"/>
           <p:nvPr>
             <p:ph type="title"/>
@@ -7773,7 +7699,7 @@
       </p:sp>
       <p:sp>
         <p:nvSpPr>
-          <p:cNvPr id="290" name="AI is still evolving at a very rapid pace.. standardization in coding practice using AI is in its infancy…"/>
+          <p:cNvPr id="288" name="AI is still evolving at a very rapid pace.. standardization in coding practice using AI is in its infancy…"/>
           <p:cNvSpPr txBox="1"/>
           <p:nvPr>
             <p:ph type="body" idx="1"/>
@@ -7873,7 +7799,7 @@
       </p:grpSpPr>
       <p:sp>
         <p:nvSpPr>
-          <p:cNvPr id="292" name="Provide references to what other developers are researching"/>
+          <p:cNvPr id="290" name="Provide references to what other developers are researching"/>
           <p:cNvSpPr txBox="1"/>
           <p:nvPr>
             <p:ph type="body" idx="21"/>
@@ -7902,7 +7828,7 @@
       </p:sp>
       <p:sp>
         <p:nvSpPr>
-          <p:cNvPr id="293" name="From other developers"/>
+          <p:cNvPr id="291" name="From other developers"/>
           <p:cNvSpPr txBox="1"/>
           <p:nvPr>
             <p:ph type="title"/>
@@ -7930,7 +7856,7 @@
       </p:sp>
       <p:sp>
         <p:nvSpPr>
-          <p:cNvPr id="294" name="Follow podcasts/ spotify/ YouTube from leading developer organizations: Thoughtworks, MartinFowler, Info-Q, ChangeLog, Software Engineering podcast; — plus the key sources: Anthropic, OpenAI, Google, Microsoft…"/>
+          <p:cNvPr id="292" name="Follow podcasts/ spotify/ YouTube from leading developer organizations: Thoughtworks, MartinFowler, Info-Q, ChangeLog, Software Engineering podcast; — plus the key sources: Anthropic, OpenAI, Google, Microsoft…"/>
           <p:cNvSpPr txBox="1"/>
           <p:nvPr>
             <p:ph type="body" idx="1"/>
@@ -8133,7 +8059,7 @@
       </p:grpSpPr>
       <p:sp>
         <p:nvSpPr>
-          <p:cNvPr id="298" name="… migrate sample application from old to new stack"/>
+          <p:cNvPr id="296" name="… migrate sample application from old to new stack"/>
           <p:cNvSpPr txBox="1"/>
           <p:nvPr>
             <p:ph type="body" idx="21"/>
@@ -8166,7 +8092,7 @@
       </p:sp>
       <p:sp>
         <p:nvSpPr>
-          <p:cNvPr id="299" name="Experiment:"/>
+          <p:cNvPr id="297" name="Experiment:"/>
           <p:cNvSpPr txBox="1"/>
           <p:nvPr>
             <p:ph type="title"/>
@@ -8307,7 +8233,7 @@
               <a:defRPr sz="2800"/>
             </a:pPr>
             <a:r>
-              <a:t>Background on AI Agents, IDEs … pages 3-5 : xxx minutes… 20%</a:t>
+              <a:t>Background on AI Agents, IDEs … pages 3-5… 10%</a:t>
             </a:r>
           </a:p>
           <a:p>
@@ -8318,7 +8244,7 @@
               <a:defRPr sz="2800"/>
             </a:pPr>
             <a:r>
-              <a:t>About Speckit … pages 6-9 : xxx minutes… 5%</a:t>
+              <a:t>About Speckit … pages 6-9 … 20%</a:t>
             </a:r>
           </a:p>
           <a:p>
@@ -8329,7 +8255,7 @@
               <a:defRPr sz="2800"/>
             </a:pPr>
             <a:r>
-              <a:t>About Skills… pages 10-11</a:t>
+              <a:t>About Skills… pages 10-11 … 10%</a:t>
             </a:r>
           </a:p>
           <a:p>
@@ -8340,7 +8266,7 @@
               <a:defRPr sz="2800"/>
             </a:pPr>
             <a:r>
-              <a:t>About Agents.md … pages 12-13</a:t>
+              <a:t>About Agents.md … pages 12-13 .. 10%</a:t>
             </a:r>
           </a:p>
           <a:p>
@@ -8351,7 +8277,7 @@
               <a:defRPr sz="2800"/>
             </a:pPr>
             <a:r>
-              <a:t>SDLC Roles with AI Agents … pages 14-16 </a:t>
+              <a:t>SDLC Roles with AI Agents … pages 14-16 .. 20% </a:t>
             </a:r>
           </a:p>
           <a:p>
@@ -8362,7 +8288,7 @@
               <a:defRPr sz="2800"/>
             </a:pPr>
             <a:r>
-              <a:t>Ending thoughts … pages 17-18 : xxx minutes… 5%</a:t>
+              <a:t>Ending thoughts … pages 17-18 … 20%</a:t>
             </a:r>
           </a:p>
           <a:p>
@@ -8373,7 +8299,18 @@
               <a:defRPr sz="2800"/>
             </a:pPr>
             <a:r>
-              <a:t>Journey of one experiment … pages 19-33 : xxx minutes… 60%</a:t>
+              <a:t>Journey of one experiment … pages 19-33  … 10%</a:t>
+            </a:r>
+          </a:p>
+          <a:p>
+            <a:pPr lvl="3">
+              <a:spcBef>
+                <a:spcPts val="1000"/>
+              </a:spcBef>
+              <a:defRPr sz="2800"/>
+            </a:pPr>
+            <a:r>
+              <a:t>(100% == 60 minutes)</a:t>
             </a:r>
           </a:p>
         </p:txBody>
@@ -8406,7 +8343,7 @@
       </p:grpSpPr>
       <p:sp>
         <p:nvSpPr>
-          <p:cNvPr id="301" name="How can AI address Legacy App??"/>
+          <p:cNvPr id="299" name="How can AI address Legacy App??"/>
           <p:cNvSpPr txBox="1"/>
           <p:nvPr>
             <p:ph type="title"/>
@@ -8432,7 +8369,7 @@
       </p:sp>
       <p:sp>
         <p:nvSpPr>
-          <p:cNvPr id="302" name="Qualities of Legacy application…"/>
+          <p:cNvPr id="300" name="Qualities of Legacy application…"/>
           <p:cNvSpPr txBox="1"/>
           <p:nvPr>
             <p:ph type="body" sz="half" idx="1"/>
@@ -8582,7 +8519,7 @@
       </p:sp>
       <p:pic>
         <p:nvPicPr>
-          <p:cNvPr id="303" name="pasted-movie.png" descr="pasted-movie.png"/>
+          <p:cNvPr id="301" name="pasted-movie.png" descr="pasted-movie.png"/>
           <p:cNvPicPr>
             <a:picLocks noChangeAspect="1"/>
           </p:cNvPicPr>
@@ -8611,7 +8548,7 @@
       </p:pic>
       <p:pic>
         <p:nvPicPr>
-          <p:cNvPr id="304" name="pasted-movie.png" descr="pasted-movie.png"/>
+          <p:cNvPr id="302" name="pasted-movie.png" descr="pasted-movie.png"/>
           <p:cNvPicPr>
             <a:picLocks noChangeAspect="1"/>
           </p:cNvPicPr>
@@ -8640,7 +8577,7 @@
       </p:pic>
       <p:pic>
         <p:nvPicPr>
-          <p:cNvPr id="305" name="pasted-movie.png" descr="pasted-movie.png"/>
+          <p:cNvPr id="303" name="pasted-movie.png" descr="pasted-movie.png"/>
           <p:cNvPicPr>
             <a:picLocks noChangeAspect="1"/>
           </p:cNvPicPr>
@@ -8669,7 +8606,7 @@
       </p:pic>
       <p:sp>
         <p:nvSpPr>
-          <p:cNvPr id="306" name="Estimate talk time: 3-5 minutes ?"/>
+          <p:cNvPr id="304" name="Estimate talk time: 3-5 minutes ?"/>
           <p:cNvSpPr txBox="1"/>
           <p:nvPr/>
         </p:nvSpPr>
@@ -8739,7 +8676,7 @@
       </p:grpSpPr>
       <p:sp>
         <p:nvSpPr>
-          <p:cNvPr id="310" name="Migrating a sample application from old tech stack to new"/>
+          <p:cNvPr id="308" name="Migrating a sample application from old tech stack to new"/>
           <p:cNvSpPr txBox="1"/>
           <p:nvPr>
             <p:ph type="body" idx="21"/>
@@ -8768,7 +8705,7 @@
       </p:sp>
       <p:sp>
         <p:nvSpPr>
-          <p:cNvPr id="311" name="About the Experiment"/>
+          <p:cNvPr id="309" name="About the Experiment"/>
           <p:cNvSpPr txBox="1"/>
           <p:nvPr>
             <p:ph type="title"/>
@@ -8796,7 +8733,7 @@
       </p:sp>
       <p:sp>
         <p:nvSpPr>
-          <p:cNvPr id="312" name="Why is this app legacy? a working application written in 2020 on older tech stack; newer versions of Java, Gradle do not support that stack; one of the key libraries is no longer supported today; a demo app with rest APIs which are expected to run 24/7 w"/>
+          <p:cNvPr id="310" name="Why is this app legacy? a working application written in 2020 on older tech stack; newer versions of Java, Gradle do not support that stack; one of the key libraries is no longer supported today; a demo app with rest APIs which are expected to run 24/7 w"/>
           <p:cNvSpPr txBox="1"/>
           <p:nvPr>
             <p:ph type="body" idx="1"/>
@@ -8909,7 +8846,7 @@
       </p:grpSpPr>
       <p:sp>
         <p:nvSpPr>
-          <p:cNvPr id="314" name="AI reviews, shows findings, Developer verifies"/>
+          <p:cNvPr id="312" name="AI reviews, shows findings, Developer verifies"/>
           <p:cNvSpPr txBox="1"/>
           <p:nvPr>
             <p:ph type="body" idx="21"/>
@@ -8946,7 +8883,7 @@
       </p:sp>
       <p:sp>
         <p:nvSpPr>
-          <p:cNvPr id="315" name="Glimpse of First Analysis"/>
+          <p:cNvPr id="313" name="Glimpse of First Analysis"/>
           <p:cNvSpPr txBox="1"/>
           <p:nvPr>
             <p:ph type="title"/>
@@ -8978,7 +8915,7 @@
       </p:sp>
       <p:sp>
         <p:nvSpPr>
-          <p:cNvPr id="316" name="Ask AI Code Assistant to analyze the codebase…"/>
+          <p:cNvPr id="314" name="Ask AI Code Assistant to analyze the codebase…"/>
           <p:cNvSpPr txBox="1"/>
           <p:nvPr>
             <p:ph type="body" sz="half" idx="1"/>
@@ -9018,7 +8955,7 @@
       </p:sp>
       <p:pic>
         <p:nvPicPr>
-          <p:cNvPr id="317" name="pasted-movie.png" descr="pasted-movie.png"/>
+          <p:cNvPr id="315" name="pasted-movie.png" descr="pasted-movie.png"/>
           <p:cNvPicPr>
             <a:picLocks noChangeAspect="1"/>
           </p:cNvPicPr>
@@ -9050,7 +8987,7 @@
       </p:pic>
       <p:pic>
         <p:nvPicPr>
-          <p:cNvPr id="318" name="pasted-movie.png" descr="pasted-movie.png"/>
+          <p:cNvPr id="316" name="pasted-movie.png" descr="pasted-movie.png"/>
           <p:cNvPicPr>
             <a:picLocks noChangeAspect="1"/>
           </p:cNvPicPr>
@@ -9082,7 +9019,7 @@
       </p:pic>
       <p:pic>
         <p:nvPicPr>
-          <p:cNvPr id="319" name="pasted-movie.png" descr="pasted-movie.png"/>
+          <p:cNvPr id="317" name="pasted-movie.png" descr="pasted-movie.png"/>
           <p:cNvPicPr>
             <a:picLocks noChangeAspect="1"/>
           </p:cNvPicPr>
@@ -9140,7 +9077,7 @@
       </p:grpSpPr>
       <p:sp>
         <p:nvSpPr>
-          <p:cNvPr id="321" name="First Analysis continued"/>
+          <p:cNvPr id="319" name="First Analysis continued"/>
           <p:cNvSpPr txBox="1"/>
           <p:nvPr>
             <p:ph type="title"/>
@@ -9168,7 +9105,7 @@
       </p:sp>
       <p:sp>
         <p:nvSpPr>
-          <p:cNvPr id="322" name="Even before I showed AI my plan for migration, it had listed correctly which features were good and which outdated.…"/>
+          <p:cNvPr id="320" name="Even before I showed AI my plan for migration, it had listed correctly which features were good and which outdated.…"/>
           <p:cNvSpPr txBox="1"/>
           <p:nvPr>
             <p:ph type="body" sz="quarter" idx="1"/>
@@ -9202,7 +9139,7 @@
       </p:sp>
       <p:pic>
         <p:nvPicPr>
-          <p:cNvPr id="323" name="pasted-movie.png" descr="pasted-movie.png"/>
+          <p:cNvPr id="321" name="pasted-movie.png" descr="pasted-movie.png"/>
           <p:cNvPicPr>
             <a:picLocks noChangeAspect="1"/>
           </p:cNvPicPr>
@@ -9234,7 +9171,7 @@
       </p:pic>
       <p:pic>
         <p:nvPicPr>
-          <p:cNvPr id="324" name="pasted-movie.png" descr="pasted-movie.png"/>
+          <p:cNvPr id="322" name="pasted-movie.png" descr="pasted-movie.png"/>
           <p:cNvPicPr>
             <a:picLocks noChangeAspect="1"/>
           </p:cNvPicPr>
@@ -9266,7 +9203,7 @@
       </p:pic>
       <p:pic>
         <p:nvPicPr>
-          <p:cNvPr id="325" name="pasted-movie.png" descr="pasted-movie.png"/>
+          <p:cNvPr id="323" name="pasted-movie.png" descr="pasted-movie.png"/>
           <p:cNvPicPr>
             <a:picLocks noChangeAspect="1"/>
           </p:cNvPicPr>
@@ -9298,7 +9235,7 @@
       </p:pic>
       <p:pic>
         <p:nvPicPr>
-          <p:cNvPr id="326" name="pasted-movie.png" descr="pasted-movie.png"/>
+          <p:cNvPr id="324" name="pasted-movie.png" descr="pasted-movie.png"/>
           <p:cNvPicPr>
             <a:picLocks noChangeAspect="1"/>
           </p:cNvPicPr>
@@ -9330,7 +9267,7 @@
       </p:pic>
       <p:sp>
         <p:nvSpPr>
-          <p:cNvPr id="327" name="After migration was completed"/>
+          <p:cNvPr id="325" name="After migration was completed"/>
           <p:cNvSpPr txBox="1"/>
           <p:nvPr/>
         </p:nvSpPr>
@@ -9395,7 +9332,7 @@
       </p:grpSpPr>
       <p:sp>
         <p:nvSpPr>
-          <p:cNvPr id="329" name="Drafting the plan"/>
+          <p:cNvPr id="327" name="Drafting the plan"/>
           <p:cNvSpPr txBox="1"/>
           <p:nvPr>
             <p:ph type="title"/>
@@ -9423,7 +9360,7 @@
       </p:sp>
       <p:sp>
         <p:nvSpPr>
-          <p:cNvPr id="330" name="Step 1: ask AI to analyze codebase; describe what this application is and what key features it has (NOTE: this later part is because I was the original developer)…"/>
+          <p:cNvPr id="328" name="Step 1: ask AI to analyze codebase; describe what this application is and what key features it has (NOTE: this later part is because I was the original developer)…"/>
           <p:cNvSpPr txBox="1"/>
           <p:nvPr>
             <p:ph type="body" idx="1"/>
@@ -9501,7 +9438,7 @@
       </p:grpSpPr>
       <p:sp>
         <p:nvSpPr>
-          <p:cNvPr id="332" name="Comparing my approach with speckit"/>
+          <p:cNvPr id="330" name="Comparing my approach with speckit"/>
           <p:cNvSpPr txBox="1"/>
           <p:nvPr>
             <p:ph type="body" idx="21"/>
@@ -9530,7 +9467,7 @@
       </p:sp>
       <p:sp>
         <p:nvSpPr>
-          <p:cNvPr id="333" name="Journey of changes"/>
+          <p:cNvPr id="331" name="Journey of changes"/>
           <p:cNvSpPr txBox="1"/>
           <p:nvPr>
             <p:ph type="title"/>
@@ -9558,7 +9495,7 @@
       </p:sp>
       <p:sp>
         <p:nvSpPr>
-          <p:cNvPr id="334" name="Further experimenting on other greenfield projects using speckit; the sequential plan I used here was in line with speckits’ specify, clarify, plan commands…"/>
+          <p:cNvPr id="332" name="Further experimenting on other greenfield projects using speckit; the sequential plan I used here was in line with speckits’ specify, clarify, plan commands…"/>
           <p:cNvSpPr txBox="1"/>
           <p:nvPr>
             <p:ph type="body" idx="1"/>
@@ -9636,7 +9573,7 @@
       </p:grpSpPr>
       <p:sp>
         <p:nvSpPr>
-          <p:cNvPr id="336" name="Compare with speckit"/>
+          <p:cNvPr id="334" name="Compare with speckit"/>
           <p:cNvSpPr txBox="1"/>
           <p:nvPr>
             <p:ph type="body" idx="21"/>
@@ -9665,7 +9602,7 @@
       </p:sp>
       <p:sp>
         <p:nvSpPr>
-          <p:cNvPr id="337" name="Backend working with new stack"/>
+          <p:cNvPr id="335" name="Backend working with new stack"/>
           <p:cNvSpPr txBox="1"/>
           <p:nvPr>
             <p:ph type="title"/>
@@ -9693,7 +9630,7 @@
       </p:sp>
       <p:sp>
         <p:nvSpPr>
-          <p:cNvPr id="338" name="In the migration experiment I had fair amount of interaction with AI to reach on a good enough upgrade; later experiments using speckit proved that if specification and plan is build with careful details, these iterations can be controlled…"/>
+          <p:cNvPr id="336" name="In the migration experiment I had fair amount of interaction with AI to reach on a good enough upgrade; later experiments using speckit proved that if specification and plan is build with careful details, these iterations can be controlled…"/>
           <p:cNvSpPr txBox="1"/>
           <p:nvPr>
             <p:ph type="body" sz="half" idx="1"/>
@@ -9748,7 +9685,7 @@
       </p:sp>
       <p:pic>
         <p:nvPicPr>
-          <p:cNvPr id="339" name="pasted-movie.png" descr="pasted-movie.png"/>
+          <p:cNvPr id="337" name="pasted-movie.png" descr="pasted-movie.png"/>
           <p:cNvPicPr>
             <a:picLocks noChangeAspect="1"/>
           </p:cNvPicPr>
@@ -9806,7 +9743,7 @@
       </p:grpSpPr>
       <p:sp>
         <p:nvSpPr>
-          <p:cNvPr id="341" name="Increase testability"/>
+          <p:cNvPr id="339" name="Increase testability"/>
           <p:cNvSpPr txBox="1"/>
           <p:nvPr>
             <p:ph type="title"/>
@@ -9834,7 +9771,7 @@
       </p:sp>
       <p:sp>
         <p:nvSpPr>
-          <p:cNvPr id="342" name="My initial test cases in the original application were only checking on the service layer, repository layer, and Aspects…"/>
+          <p:cNvPr id="340" name="My initial test cases in the original application were only checking on the service layer, repository layer, and Aspects…"/>
           <p:cNvSpPr txBox="1"/>
           <p:nvPr>
             <p:ph type="body" idx="1"/>
@@ -9906,7 +9843,7 @@
       </p:grpSpPr>
       <p:sp>
         <p:nvSpPr>
-          <p:cNvPr id="344" name="Adding new feature"/>
+          <p:cNvPr id="342" name="Adding new feature"/>
           <p:cNvSpPr txBox="1"/>
           <p:nvPr>
             <p:ph type="title"/>
@@ -9934,7 +9871,7 @@
       </p:sp>
       <p:sp>
         <p:nvSpPr>
-          <p:cNvPr id="345" name="This app was not having a client for the API — either a web-frontend or a CLI; so next came feature additions now that the essential upgrade was done.…"/>
+          <p:cNvPr id="343" name="This app was not having a client for the API — either a web-frontend or a CLI; so next came feature additions now that the essential upgrade was done.…"/>
           <p:cNvSpPr txBox="1"/>
           <p:nvPr>
             <p:ph type="body" idx="1"/>
@@ -10000,7 +9937,7 @@
       </p:grpSpPr>
       <p:sp>
         <p:nvSpPr>
-          <p:cNvPr id="347" name="Adding documentation for the app"/>
+          <p:cNvPr id="345" name="Adding documentation for the app"/>
           <p:cNvSpPr txBox="1"/>
           <p:nvPr>
             <p:ph type="title"/>
@@ -10028,7 +9965,7 @@
       </p:sp>
       <p:sp>
         <p:nvSpPr>
-          <p:cNvPr id="348" name="Over the 5 week period working with AI to migrate the legacy application to new tech stack, I had been making my notes each day. After both backend and frontend were working as desired, now was a good time to capture all notes in the repository itself…"/>
+          <p:cNvPr id="346" name="Over the 5 week period working with AI to migrate the legacy application to new tech stack, I had been making my notes each day. After both backend and frontend were working as desired, now was a good time to capture all notes in the repository itself…"/>
           <p:cNvSpPr txBox="1"/>
           <p:nvPr>
             <p:ph type="body" idx="1"/>
@@ -10088,7 +10025,7 @@
       </p:grpSpPr>
       <p:sp>
         <p:nvSpPr>
-          <p:cNvPr id="180" name="Background on AI Code Assistants"/>
+          <p:cNvPr id="178" name="Background on AI Code Assistants"/>
           <p:cNvSpPr txBox="1"/>
           <p:nvPr>
             <p:ph type="title"/>
@@ -10114,7 +10051,7 @@
       </p:sp>
       <p:sp>
         <p:nvSpPr>
-          <p:cNvPr id="181" name="AI does not replace a task; it augments and helps with automation; work is still done by the developer…"/>
+          <p:cNvPr id="179" name="AI does not replace a task; it augments and helps with automation; work is still done by the developer…"/>
           <p:cNvSpPr txBox="1"/>
           <p:nvPr>
             <p:ph type="body" idx="1"/>
@@ -10247,7 +10184,7 @@
       </p:sp>
       <p:sp>
         <p:nvSpPr>
-          <p:cNvPr id="182" name="Estimate talk time: 3-5 minutes ?"/>
+          <p:cNvPr id="180" name="Estimate talk time: 3-5 minutes ?"/>
           <p:cNvSpPr txBox="1"/>
           <p:nvPr/>
         </p:nvSpPr>
@@ -10317,7 +10254,7 @@
       </p:grpSpPr>
       <p:sp>
         <p:nvSpPr>
-          <p:cNvPr id="350" name="Re-arrange docs to Mkdocs"/>
+          <p:cNvPr id="348" name="Re-arrange docs to Mkdocs"/>
           <p:cNvSpPr txBox="1"/>
           <p:nvPr>
             <p:ph type="title"/>
@@ -10345,7 +10282,7 @@
       </p:sp>
       <p:sp>
         <p:nvSpPr>
-          <p:cNvPr id="351" name="For my experiment, I hand crafted the mkdocs for this application using documentation generated by AI…"/>
+          <p:cNvPr id="349" name="For my experiment, I hand crafted the mkdocs for this application using documentation generated by AI…"/>
           <p:cNvSpPr txBox="1"/>
           <p:nvPr>
             <p:ph type="body" idx="1"/>
@@ -10411,7 +10348,7 @@
       </p:grpSpPr>
       <p:sp>
         <p:nvSpPr>
-          <p:cNvPr id="353" name="Summarizing this experiment"/>
+          <p:cNvPr id="351" name="Summarizing this experiment"/>
           <p:cNvSpPr txBox="1"/>
           <p:nvPr>
             <p:ph type="title"/>
@@ -10439,7 +10376,7 @@
       </p:sp>
       <p:sp>
         <p:nvSpPr>
-          <p:cNvPr id="354" name="As my first experiment playing with AI Code Assistant, this did give me insight on how I should be interacting with AI…"/>
+          <p:cNvPr id="352" name="As my first experiment playing with AI Code Assistant, this did give me insight on how I should be interacting with AI…"/>
           <p:cNvSpPr txBox="1"/>
           <p:nvPr>
             <p:ph type="body" idx="1"/>
@@ -10505,7 +10442,7 @@
       </p:grpSpPr>
       <p:sp>
         <p:nvSpPr>
-          <p:cNvPr id="356" name="… extra pages"/>
+          <p:cNvPr id="354" name="… extra pages"/>
           <p:cNvSpPr txBox="1"/>
           <p:nvPr>
             <p:ph type="body" idx="21"/>
@@ -10538,7 +10475,7 @@
       </p:sp>
       <p:sp>
         <p:nvSpPr>
-          <p:cNvPr id="357" name="Appendix"/>
+          <p:cNvPr id="355" name="Appendix"/>
           <p:cNvSpPr txBox="1"/>
           <p:nvPr>
             <p:ph type="title"/>
@@ -10607,7 +10544,7 @@
       </p:grpSpPr>
       <p:sp>
         <p:nvSpPr>
-          <p:cNvPr id="359" name="“Working effectively with Legacy Code” by Michael Feathers (2004)"/>
+          <p:cNvPr id="357" name="“Working effectively with Legacy Code” by Michael Feathers (2004)"/>
           <p:cNvSpPr txBox="1"/>
           <p:nvPr>
             <p:ph type="body" idx="21"/>
@@ -10636,7 +10573,7 @@
       </p:sp>
       <p:sp>
         <p:nvSpPr>
-          <p:cNvPr id="360" name="Old advice is still relevant"/>
+          <p:cNvPr id="358" name="Old advice is still relevant"/>
           <p:cNvSpPr txBox="1"/>
           <p:nvPr>
             <p:ph type="title"/>
@@ -10664,7 +10601,7 @@
       </p:sp>
       <p:sp>
         <p:nvSpPr>
-          <p:cNvPr id="361" name="First add tests and then do your changes…"/>
+          <p:cNvPr id="359" name="First add tests and then do your changes…"/>
           <p:cNvSpPr txBox="1"/>
           <p:nvPr>
             <p:ph type="body" idx="1"/>
@@ -10774,7 +10711,7 @@
       </p:grpSpPr>
       <p:sp>
         <p:nvSpPr>
-          <p:cNvPr id="186" name="Large number of IDEs available with similar capabilities"/>
+          <p:cNvPr id="184" name="Large number of IDEs available with similar capabilities"/>
           <p:cNvSpPr txBox="1"/>
           <p:nvPr>
             <p:ph type="body" idx="21"/>
@@ -10803,7 +10740,7 @@
       </p:sp>
       <p:sp>
         <p:nvSpPr>
-          <p:cNvPr id="187" name="Which IDE to use?"/>
+          <p:cNvPr id="185" name="Which IDE to use?"/>
           <p:cNvSpPr txBox="1"/>
           <p:nvPr>
             <p:ph type="title"/>
@@ -10831,7 +10768,7 @@
       </p:sp>
       <p:sp>
         <p:nvSpPr>
-          <p:cNvPr id="188" name="All AI Code Assistants have similar capabilities— it is developers choice which one to use…"/>
+          <p:cNvPr id="186" name="All AI Code Assistants have similar capabilities— it is developers choice which one to use…"/>
           <p:cNvSpPr txBox="1"/>
           <p:nvPr>
             <p:ph type="body" idx="1"/>
@@ -10914,7 +10851,7 @@
       </p:grpSpPr>
       <p:sp>
         <p:nvSpPr>
-          <p:cNvPr id="192" name="Which ones to use? And when? — Its developers choice/ taste — try different models — below is one example"/>
+          <p:cNvPr id="190" name="Which ones to use? And when? — Its developers choice/ taste — try different models — below is one example"/>
           <p:cNvSpPr txBox="1"/>
           <p:nvPr>
             <p:ph type="body" idx="21"/>
@@ -10947,7 +10884,7 @@
       </p:sp>
       <p:sp>
         <p:nvSpPr>
-          <p:cNvPr id="193" name="LLM models"/>
+          <p:cNvPr id="191" name="LLM models"/>
           <p:cNvSpPr txBox="1"/>
           <p:nvPr>
             <p:ph type="title"/>
@@ -10975,7 +10912,7 @@
       </p:sp>
       <p:sp>
         <p:nvSpPr>
-          <p:cNvPr id="194" name="I want to control: Kind of tasks?…"/>
+          <p:cNvPr id="192" name="I want to control: Kind of tasks?…"/>
           <p:cNvSpPr txBox="1"/>
           <p:nvPr>
             <p:ph type="body" sz="half" idx="1"/>
@@ -11090,7 +11027,7 @@
       </p:sp>
       <p:sp>
         <p:nvSpPr>
-          <p:cNvPr id="195" name="AI should take control: Task Complexity?…"/>
+          <p:cNvPr id="193" name="AI should take control: Task Complexity?…"/>
           <p:cNvSpPr txBox="1"/>
           <p:nvPr/>
         </p:nvSpPr>
@@ -11240,7 +11177,7 @@
       </p:sp>
       <p:sp>
         <p:nvSpPr>
-          <p:cNvPr id="196" name="How much control do you want?"/>
+          <p:cNvPr id="194" name="How much control do you want?"/>
           <p:cNvSpPr txBox="1"/>
           <p:nvPr/>
         </p:nvSpPr>
@@ -11307,7 +11244,7 @@
       </p:grpSpPr>
       <p:sp>
         <p:nvSpPr>
-          <p:cNvPr id="198" name="Background for SpecKit"/>
+          <p:cNvPr id="196" name="Background for SpecKit"/>
           <p:cNvSpPr txBox="1"/>
           <p:nvPr>
             <p:ph type="title"/>
@@ -11335,7 +11272,7 @@
       </p:sp>
       <p:pic>
         <p:nvPicPr>
-          <p:cNvPr id="199" name="pasted-movie.png" descr="pasted-movie.png"/>
+          <p:cNvPr id="197" name="pasted-movie.png" descr="pasted-movie.png"/>
           <p:cNvPicPr>
             <a:picLocks noChangeAspect="1"/>
           </p:cNvPicPr>
@@ -11364,7 +11301,7 @@
       </p:pic>
       <p:pic>
         <p:nvPicPr>
-          <p:cNvPr id="200" name="pasted-movie.png" descr="pasted-movie.png"/>
+          <p:cNvPr id="198" name="pasted-movie.png" descr="pasted-movie.png"/>
           <p:cNvPicPr>
             <a:picLocks noChangeAspect="1"/>
           </p:cNvPicPr>
@@ -11393,7 +11330,7 @@
       </p:pic>
       <p:sp>
         <p:nvSpPr>
-          <p:cNvPr id="201" name="SpecKit provides set of templates for AI Code Assistants (pull the latest).. use CLI to configure these templates for your Code Assistant or setup manually…"/>
+          <p:cNvPr id="199" name="SpecKit provides set of templates for AI Code Assistants (pull the latest).. use CLI to configure these templates for your Code Assistant or setup manually…"/>
           <p:cNvSpPr txBox="1"/>
           <p:nvPr>
             <p:ph type="body" sz="half" idx="1"/>
@@ -11473,7 +11410,7 @@
       </p:sp>
       <p:sp>
         <p:nvSpPr>
-          <p:cNvPr id="202" name="Estimate talk time: 3-5 minutes ?"/>
+          <p:cNvPr id="200" name="Estimate talk time: 3-5 minutes ?"/>
           <p:cNvSpPr txBox="1"/>
           <p:nvPr/>
         </p:nvSpPr>
@@ -11543,7 +11480,7 @@
       </p:grpSpPr>
       <p:sp>
         <p:nvSpPr>
-          <p:cNvPr id="206" name="Handy links to documentation, explanation"/>
+          <p:cNvPr id="204" name="Handy links to documentation, explanation"/>
           <p:cNvSpPr txBox="1"/>
           <p:nvPr>
             <p:ph type="body" idx="21"/>
@@ -11572,7 +11509,7 @@
       </p:sp>
       <p:sp>
         <p:nvSpPr>
-          <p:cNvPr id="207" name="Resources on Speckit"/>
+          <p:cNvPr id="205" name="Resources on Speckit"/>
           <p:cNvSpPr txBox="1"/>
           <p:nvPr>
             <p:ph type="title"/>
@@ -11600,7 +11537,7 @@
       </p:sp>
       <p:sp>
         <p:nvSpPr>
-          <p:cNvPr id="208" name="From the creators:…"/>
+          <p:cNvPr id="206" name="From the creators:…"/>
           <p:cNvSpPr txBox="1"/>
           <p:nvPr>
             <p:ph type="body" idx="1"/>
@@ -11765,7 +11702,7 @@
       </p:grpSpPr>
       <p:sp>
         <p:nvSpPr>
-          <p:cNvPr id="210" name="Two similar toolkits"/>
+          <p:cNvPr id="208" name="Two similar toolkits"/>
           <p:cNvSpPr txBox="1"/>
           <p:nvPr>
             <p:ph type="body" idx="21"/>
@@ -11794,7 +11731,7 @@
       </p:sp>
       <p:sp>
         <p:nvSpPr>
-          <p:cNvPr id="211" name="Comparing with OpenSpec"/>
+          <p:cNvPr id="209" name="Comparing with OpenSpec"/>
           <p:cNvSpPr txBox="1"/>
           <p:nvPr>
             <p:ph type="title"/>
@@ -11822,7 +11759,7 @@
       </p:sp>
       <p:graphicFrame>
         <p:nvGraphicFramePr>
-          <p:cNvPr id="212" name="Table 1"/>
+          <p:cNvPr id="210" name="Table 1"/>
           <p:cNvGraphicFramePr/>
           <p:nvPr/>
         </p:nvGraphicFramePr>
@@ -12241,7 +12178,7 @@
       </p:grpSpPr>
       <p:sp>
         <p:nvSpPr>
-          <p:cNvPr id="216" name="Command Workflow"/>
+          <p:cNvPr id="214" name="Command Workflow"/>
           <p:cNvSpPr txBox="1"/>
           <p:nvPr>
             <p:ph type="title"/>
@@ -12269,7 +12206,7 @@
       </p:sp>
       <p:sp>
         <p:nvSpPr>
-          <p:cNvPr id="217" name="Basic: constitution —&gt; specify —&gt; plan —&gt; tasks —&gt; implement…"/>
+          <p:cNvPr id="215" name="Basic: constitution —&gt; specify —&gt; plan —&gt; tasks —&gt; implement…"/>
           <p:cNvSpPr txBox="1"/>
           <p:nvPr>
             <p:ph type="body" sz="half" idx="1"/>
@@ -12303,7 +12240,7 @@
       </p:sp>
       <p:sp>
         <p:nvSpPr>
-          <p:cNvPr id="218" name="/constitution project principles, standards"/>
+          <p:cNvPr id="216" name="/constitution project principles, standards"/>
           <p:cNvSpPr/>
           <p:nvPr/>
         </p:nvSpPr>
@@ -12347,7 +12284,7 @@
       </p:sp>
       <p:sp>
         <p:nvSpPr>
-          <p:cNvPr id="219" name="Rectangle"/>
+          <p:cNvPr id="217" name="Rectangle"/>
           <p:cNvSpPr/>
           <p:nvPr/>
         </p:nvSpPr>
@@ -12385,7 +12322,7 @@
       </p:sp>
       <p:sp>
         <p:nvSpPr>
-          <p:cNvPr id="220" name="/specify define what you need (no tech info)"/>
+          <p:cNvPr id="218" name="/specify define what you need (no tech info)"/>
           <p:cNvSpPr/>
           <p:nvPr/>
         </p:nvSpPr>
@@ -12436,7 +12373,7 @@
       </p:sp>
       <p:sp>
         <p:nvSpPr>
-          <p:cNvPr id="221" name="/clarify follow up questions"/>
+          <p:cNvPr id="219" name="/clarify follow up questions"/>
           <p:cNvSpPr/>
           <p:nvPr/>
         </p:nvSpPr>
@@ -12484,7 +12421,7 @@
       </p:sp>
       <p:sp>
         <p:nvSpPr>
-          <p:cNvPr id="222" name="/plan implementation plan"/>
+          <p:cNvPr id="220" name="/plan implementation plan"/>
           <p:cNvSpPr/>
           <p:nvPr/>
         </p:nvSpPr>
@@ -12535,7 +12472,7 @@
       </p:sp>
       <p:sp>
         <p:nvSpPr>
-          <p:cNvPr id="223" name="/tasks break plan into actionable steps"/>
+          <p:cNvPr id="221" name="/tasks break plan into actionable steps"/>
           <p:cNvSpPr/>
           <p:nvPr/>
         </p:nvSpPr>
@@ -12586,7 +12523,7 @@
       </p:sp>
       <p:sp>
         <p:nvSpPr>
-          <p:cNvPr id="224" name="/implement execute tasks, text"/>
+          <p:cNvPr id="222" name="/implement execute tasks, text"/>
           <p:cNvSpPr/>
           <p:nvPr/>
         </p:nvSpPr>
@@ -12637,7 +12574,7 @@
       </p:sp>
       <p:sp>
         <p:nvSpPr>
-          <p:cNvPr id="225" name="/analyze validate documents"/>
+          <p:cNvPr id="223" name="/analyze validate documents"/>
           <p:cNvSpPr/>
           <p:nvPr/>
         </p:nvSpPr>
@@ -12685,7 +12622,7 @@
       </p:sp>
       <p:sp>
         <p:nvSpPr>
-          <p:cNvPr id="226" name="Commit: pull request, merge"/>
+          <p:cNvPr id="224" name="Commit: pull request, merge"/>
           <p:cNvSpPr/>
           <p:nvPr/>
         </p:nvSpPr>
@@ -12733,7 +12670,7 @@
       </p:sp>
       <p:sp>
         <p:nvSpPr>
-          <p:cNvPr id="227" name="Line"/>
+          <p:cNvPr id="225" name="Line"/>
           <p:cNvSpPr/>
           <p:nvPr/>
         </p:nvSpPr>
@@ -12766,7 +12703,7 @@
       </p:sp>
       <p:sp>
         <p:nvSpPr>
-          <p:cNvPr id="228" name="Line"/>
+          <p:cNvPr id="226" name="Line"/>
           <p:cNvSpPr/>
           <p:nvPr/>
         </p:nvSpPr>
@@ -12799,7 +12736,7 @@
       </p:sp>
       <p:sp>
         <p:nvSpPr>
-          <p:cNvPr id="229" name="Line"/>
+          <p:cNvPr id="227" name="Line"/>
           <p:cNvSpPr/>
           <p:nvPr/>
         </p:nvSpPr>
@@ -12832,7 +12769,7 @@
       </p:sp>
       <p:sp>
         <p:nvSpPr>
-          <p:cNvPr id="230" name="Line"/>
+          <p:cNvPr id="228" name="Line"/>
           <p:cNvSpPr/>
           <p:nvPr/>
         </p:nvSpPr>
@@ -12865,7 +12802,7 @@
       </p:sp>
       <p:sp>
         <p:nvSpPr>
-          <p:cNvPr id="231" name="Line"/>
+          <p:cNvPr id="229" name="Line"/>
           <p:cNvSpPr/>
           <p:nvPr/>
         </p:nvSpPr>
@@ -12898,7 +12835,7 @@
       </p:sp>
       <p:sp>
         <p:nvSpPr>
-          <p:cNvPr id="232" name="Line"/>
+          <p:cNvPr id="230" name="Line"/>
           <p:cNvSpPr/>
           <p:nvPr/>
         </p:nvSpPr>
@@ -12931,7 +12868,7 @@
       </p:sp>
       <p:sp>
         <p:nvSpPr>
-          <p:cNvPr id="233" name="Line"/>
+          <p:cNvPr id="231" name="Line"/>
           <p:cNvSpPr/>
           <p:nvPr/>
         </p:nvSpPr>
@@ -12964,7 +12901,7 @@
       </p:sp>
       <p:sp>
         <p:nvSpPr>
-          <p:cNvPr id="234" name="Line"/>
+          <p:cNvPr id="232" name="Line"/>
           <p:cNvSpPr/>
           <p:nvPr/>
         </p:nvSpPr>
@@ -12997,7 +12934,7 @@
       </p:sp>
       <p:sp>
         <p:nvSpPr>
-          <p:cNvPr id="235" name="Line"/>
+          <p:cNvPr id="233" name="Line"/>
           <p:cNvSpPr/>
           <p:nvPr/>
         </p:nvSpPr>
@@ -13029,7 +12966,7 @@
       </p:sp>
       <p:sp>
         <p:nvSpPr>
-          <p:cNvPr id="236" name="Line"/>
+          <p:cNvPr id="234" name="Line"/>
           <p:cNvSpPr/>
           <p:nvPr/>
         </p:nvSpPr>

</xml_diff>